<commit_message>
feat(pptx): add template content linting
</commit_message>
<xml_diff>
--- a/plugin/tests/fixtures/pptx/ecosystem_bc/templates/cjk-capacity.pptx
+++ b/plugin/tests/fixtures/pptx/ecosystem_bc/templates/cjk-capacity.pptx
@@ -901,13 +901,13 @@
           <a:lstStyle/>
           <a:p>
             <a:r>
-              <a:rPr sz="1800">
+              <a:rPr sz="3600">
                 <a:solidFill>
                   <a:srgbClr val="222222"/>
                 </a:solidFill>
                 <a:latin typeface="Calibri"/>
               </a:rPr>
-              <a:t>这是一个明显超过推荐容量并用于验证中文字符计数与层级字号检查的超长标题</a:t>
+              <a:t>正文层级反转</a:t>
             </a:r>
           </a:p>
         </p:txBody>
@@ -954,7 +954,7 @@
                 </a:solidFill>
                 <a:latin typeface="Calibri Light"/>
               </a:rPr>
-              <a:t>Template page 1</a:t>
+              <a:t>这是一个明显超过推荐容量并用于验证中文字符计数与层级字号检查的超长标题</a:t>
             </a:r>
           </a:p>
         </p:txBody>
@@ -1073,7 +1073,7 @@
                           </a:solidFill>
                           <a:latin typeface="Calibri"/>
                         </a:rPr>
-                        <a:t>Metric</a:t>
+                        <a:t>指标</a:t>
                       </a:r>
                     </a:p>
                   </a:txBody>

</xml_diff>

<commit_message>
fix(pptx): emit PowerPoint-safe speaker notes
Co-Authored-By: Claude Opus 5 (1M context) <noreply@anthropic.com>
</commit_message>
<xml_diff>
--- a/plugin/tests/fixtures/pptx/ecosystem_bc/templates/cjk-capacity.pptx
+++ b/plugin/tests/fixtures/pptx/ecosystem_bc/templates/cjk-capacity.pptx
@@ -1451,4 +1451,132 @@
     </a:fmtScheme>
   </a:themeElements>
 </a:theme>
+</file>
+
+<file path=ppt/theme/theme2.xml><?xml version="1.0" encoding="utf-8"?>
+<a:theme xmlns:a="http://schemas.openxmlformats.org/drawingml/2006/main" name="Elftia Office">
+  <a:themeElements>
+    <a:clrScheme name="Elftia Office">
+      <a:dk1>
+        <a:sysClr val="windowText" lastClr="000000"/>
+      </a:dk1>
+      <a:lt1>
+        <a:sysClr val="window" lastClr="FFFFFF"/>
+      </a:lt1>
+      <a:dk2>
+        <a:srgbClr val="44546A"/>
+      </a:dk2>
+      <a:lt2>
+        <a:srgbClr val="E7E6E6"/>
+      </a:lt2>
+      <a:accent1>
+        <a:srgbClr val="4472C4"/>
+      </a:accent1>
+      <a:accent2>
+        <a:srgbClr val="ED7D31"/>
+      </a:accent2>
+      <a:accent3>
+        <a:srgbClr val="A5A5A5"/>
+      </a:accent3>
+      <a:accent4>
+        <a:srgbClr val="FFC000"/>
+      </a:accent4>
+      <a:accent5>
+        <a:srgbClr val="5B9BD5"/>
+      </a:accent5>
+      <a:accent6>
+        <a:srgbClr val="70AD47"/>
+      </a:accent6>
+      <a:hlink>
+        <a:srgbClr val="0563C1"/>
+      </a:hlink>
+      <a:folHlink>
+        <a:srgbClr val="954F72"/>
+      </a:folHlink>
+    </a:clrScheme>
+    <a:fontScheme name="Elftia Office">
+      <a:majorFont>
+        <a:latin typeface="Calibri Light"/>
+        <a:ea typeface=""/>
+        <a:cs typeface=""/>
+      </a:majorFont>
+      <a:minorFont>
+        <a:latin typeface="Calibri"/>
+        <a:ea typeface=""/>
+        <a:cs typeface=""/>
+      </a:minorFont>
+    </a:fontScheme>
+    <a:fmtScheme>
+      <a:fillStyleLst>
+        <a:solidFill>
+          <a:schemeClr val="phClr"/>
+        </a:solidFill>
+        <a:gradFill>
+          <a:gsLst>
+            <a:gs pos="0">
+              <a:schemeClr val="phClr"/>
+            </a:gs>
+            <a:gs pos="100000">
+              <a:schemeClr val="phClr"/>
+            </a:gs>
+          </a:gsLst>
+          <a:lin ang="0" scaled="0"/>
+        </a:gradFill>
+        <a:gradFill>
+          <a:gsLst>
+            <a:gs pos="0">
+              <a:schemeClr val="phClr"/>
+            </a:gs>
+            <a:gs pos="100000">
+              <a:schemeClr val="phClr"/>
+            </a:gs>
+          </a:gsLst>
+          <a:lin ang="0" scaled="0"/>
+        </a:gradFill>
+      </a:fillStyleLst>
+      <a:lnStyleLst>
+        <a:ln w="9100" cap="flat" cmpd="sng" algn="ctr">
+          <a:solidFill>
+            <a:schemeClr val="phClr"/>
+          </a:solidFill>
+          <a:prstDash val="solid"/>
+        </a:ln>
+        <a:ln w="9100" cap="flat" cmpd="sng" algn="ctr">
+          <a:solidFill>
+            <a:schemeClr val="phClr"/>
+          </a:solidFill>
+          <a:prstDash val="solid"/>
+        </a:ln>
+        <a:ln w="9100" cap="flat" cmpd="sng" algn="ctr">
+          <a:solidFill>
+            <a:schemeClr val="phClr"/>
+          </a:solidFill>
+          <a:prstDash val="solid"/>
+        </a:ln>
+      </a:lnStyleLst>
+      <a:effectStyleLst>
+        <a:effectStyle>
+          <a:effectLst/>
+        </a:effectStyle>
+        <a:effectStyle>
+          <a:effectLst/>
+        </a:effectStyle>
+        <a:effectStyle>
+          <a:effectLst/>
+        </a:effectStyle>
+      </a:effectStyleLst>
+      <a:bgFillStyleLst>
+        <a:solidFill>
+          <a:schemeClr val="phClr"/>
+        </a:solidFill>
+        <a:solidFill>
+          <a:schemeClr val="phClr"/>
+        </a:solidFill>
+        <a:solidFill>
+          <a:schemeClr val="phClr"/>
+        </a:solidFill>
+      </a:bgFillStyleLst>
+    </a:fmtScheme>
+  </a:themeElements>
+</a:theme>
 </file>
</xml_diff>